<commit_message>
PPT: team name only in the ovals; Team ID stays on slide 1
Co-Authored-By: Claude Opus 5.5 <noreply@anthropic.com>
</commit_message>
<xml_diff>
--- a/ppt/RASAD_SIH26251.pptx
+++ b/ppt/RASAD_SIH26251.pptx
@@ -6078,21 +6078,10 @@
           <a:p>
             <a:pPr algn="ctr"/>
             <a:r>
-              <a:rPr lang="en-US" dirty="0" sz="1150" b="1"/>
+              <a:rPr lang="en-US" dirty="0" sz="1200" b="1"/>
               <a:t>Code ZCrew</a:t>
             </a:r>
             <a:endParaRPr lang="en-IN" dirty="0"/>
-          </a:p>
-          <a:p>
-            <a:pPr algn="ctr"/>
-            <a:r>
-              <a:rPr sz="1050">
-                <a:solidFill>
-                  <a:srgbClr val="404040"/>
-                </a:solidFill>
-              </a:rPr>
-              <a:t>ID 163616</a:t>
-            </a:r>
           </a:p>
         </p:txBody>
       </p:sp>
@@ -7296,21 +7285,10 @@
           <a:p>
             <a:pPr algn="ctr"/>
             <a:r>
-              <a:rPr lang="en-US" dirty="0" sz="1150" b="1"/>
+              <a:rPr lang="en-US" dirty="0" sz="1200" b="1"/>
               <a:t>Code ZCrew</a:t>
             </a:r>
             <a:endParaRPr lang="en-IN" dirty="0"/>
-          </a:p>
-          <a:p>
-            <a:pPr algn="ctr"/>
-            <a:r>
-              <a:rPr sz="1050">
-                <a:solidFill>
-                  <a:srgbClr val="404040"/>
-                </a:solidFill>
-              </a:rPr>
-              <a:t>ID 163616</a:t>
-            </a:r>
           </a:p>
         </p:txBody>
       </p:sp>
@@ -8973,21 +8951,10 @@
           <a:p>
             <a:pPr algn="ctr"/>
             <a:r>
-              <a:rPr lang="en-US" dirty="0" sz="1150" b="1"/>
+              <a:rPr lang="en-US" dirty="0" sz="1200" b="1"/>
               <a:t>Code ZCrew</a:t>
             </a:r>
             <a:endParaRPr lang="en-IN" dirty="0"/>
-          </a:p>
-          <a:p>
-            <a:pPr algn="ctr"/>
-            <a:r>
-              <a:rPr sz="1050">
-                <a:solidFill>
-                  <a:srgbClr val="404040"/>
-                </a:solidFill>
-              </a:rPr>
-              <a:t>ID 163616</a:t>
-            </a:r>
           </a:p>
         </p:txBody>
       </p:sp>
@@ -10281,21 +10248,10 @@
           <a:p>
             <a:pPr algn="ctr"/>
             <a:r>
-              <a:rPr lang="en-US" dirty="0" sz="1150" b="1"/>
+              <a:rPr lang="en-US" dirty="0" sz="1200" b="1"/>
               <a:t>Code ZCrew</a:t>
             </a:r>
             <a:endParaRPr lang="en-IN" dirty="0"/>
-          </a:p>
-          <a:p>
-            <a:pPr algn="ctr"/>
-            <a:r>
-              <a:rPr sz="1050">
-                <a:solidFill>
-                  <a:srgbClr val="404040"/>
-                </a:solidFill>
-              </a:rPr>
-              <a:t>ID 163616</a:t>
-            </a:r>
           </a:p>
         </p:txBody>
       </p:sp>
@@ -12035,21 +11991,10 @@
           <a:p>
             <a:pPr algn="ctr"/>
             <a:r>
-              <a:rPr lang="en-US" dirty="0" sz="1150" b="1"/>
+              <a:rPr lang="en-US" dirty="0" sz="1200" b="1"/>
               <a:t>Code ZCrew</a:t>
             </a:r>
             <a:endParaRPr lang="en-IN" dirty="0"/>
-          </a:p>
-          <a:p>
-            <a:pPr algn="ctr"/>
-            <a:r>
-              <a:rPr sz="1050">
-                <a:solidFill>
-                  <a:srgbClr val="404040"/>
-                </a:solidFill>
-              </a:rPr>
-              <a:t>ID 163616</a:t>
-            </a:r>
           </a:p>
         </p:txBody>
       </p:sp>

</xml_diff>